<commit_message>
Update PPT presentation and server with permanent GitHub Pages live link
</commit_message>
<xml_diff>
--- a/Agro_Sphere_SIH2026_Idea_Presentation.pptx
+++ b/Agro_Sphere_SIH2026_Idea_Presentation.pptx
@@ -5852,7 +5852,7 @@
                   <a:srgbClr val="2D2D2D"/>
                 </a:solidFill>
               </a:rPr>
-              <a:t>https://agrosphere-app.vercel.app</a:t>
+              <a:t>https://agrosphere06-ui.github.io/Agro.sphere/</a:t>
             </a:r>
           </a:p>
         </p:txBody>
@@ -8538,7 +8538,7 @@
               </a:defRPr>
             </a:pPr>
             <a:r>
-              <a:t>• Live Web Prototype: https://agrosphere-app.vercel.app</a:t>
+              <a:t>• Live Web Platform: https://agrosphere06-ui.github.io/Agro.sphere/</a:t>
             </a:r>
           </a:p>
           <a:p>

</xml_diff>